<commit_message>
feat(caregiver-cluster): add Tier decision table, review queue, Tier 1 overlap heatmap, and onboarding documentation
- Operationalize final bot declaration policy in table_37_bot_declaration_policy.csv
- Add table_38_dirty4581_review_queue.csv containing dirty_4581 records with >=2 Tier 1 hits for manual adjudication
- Generate figure_22_tier1_overlap_heatmap (PNG + PDF) for meeting slides
- Integrate Section 3b into caregiver_cluster_simple_metrics.ipynb with clean pre-executed outputs
- Add 7 unit tests in test_bot_declaration_policy.py (13/13 total tests passing)
- Comprehensive rewrite of README.md with directory organization and plain-language onboarding guides
- Add robust asset/font fallbacks in build_simple_deck.py and build_notebook.py
</commit_message>
<xml_diff>
--- a/projects/caregiver-cluster-analysis/ESD_Caregiver_Findings_Plain_Language.pptx
+++ b/projects/caregiver-cluster-analysis/ESD_Caregiver_Findings_Plain_Language.pptx
@@ -4879,33 +4879,9 @@
           </a:p>
         </p:txBody>
       </p:sp>
-      <p:pic>
-        <p:nvPicPr>
-          <p:cNvPr id="3" name="Picture 2" descr="pattern-icon-band-white.png"/>
-          <p:cNvPicPr>
-            <a:picLocks noChangeAspect="1"/>
-          </p:cNvPicPr>
-          <p:nvPr/>
-        </p:nvPicPr>
-        <p:blipFill>
-          <a:blip r:embed="rId2"/>
-          <a:stretch>
-            <a:fillRect/>
-          </a:stretch>
-        </p:blipFill>
-        <p:spPr>
-          <a:xfrm>
-            <a:off x="-548640" y="5074920"/>
-            <a:ext cx="13258800" cy="2194560"/>
-          </a:xfrm>
-          <a:prstGeom prst="rect">
-            <a:avLst/>
-          </a:prstGeom>
-        </p:spPr>
-      </p:pic>
-      <p:sp>
-        <p:nvSpPr>
-          <p:cNvPr id="4" name="Rounded Rectangle 3"/>
+      <p:sp>
+        <p:nvSpPr>
+          <p:cNvPr id="3" name="Rounded Rectangle 2"/>
           <p:cNvSpPr/>
           <p:nvPr/>
         </p:nvSpPr>
@@ -4949,57 +4925,87 @@
           </a:p>
         </p:txBody>
       </p:sp>
-      <p:pic>
-        <p:nvPicPr>
-          <p:cNvPr id="5" name="Picture 4" descr="logo-horizontal-discovery-blue.png"/>
-          <p:cNvPicPr>
-            <a:picLocks noChangeAspect="1"/>
-          </p:cNvPicPr>
-          <p:nvPr/>
-        </p:nvPicPr>
-        <p:blipFill>
-          <a:blip r:embed="rId3"/>
-          <a:stretch>
-            <a:fillRect/>
-          </a:stretch>
-        </p:blipFill>
+      <p:sp>
+        <p:nvSpPr>
+          <p:cNvPr id="4" name="TextBox 3"/>
+          <p:cNvSpPr txBox="1"/>
+          <p:nvPr/>
+        </p:nvSpPr>
         <p:spPr>
           <a:xfrm>
             <a:off x="841247" y="603504"/>
-            <a:ext cx="896323" cy="420624"/>
-          </a:xfrm>
-          <a:prstGeom prst="rect">
-            <a:avLst/>
-          </a:prstGeom>
-        </p:spPr>
-      </p:pic>
-      <p:pic>
-        <p:nvPicPr>
-          <p:cNvPr id="6" name="Picture 5" descr="uofsc-horizontal-garnet.png"/>
-          <p:cNvPicPr>
-            <a:picLocks noChangeAspect="1"/>
-          </p:cNvPicPr>
-          <p:nvPr/>
-        </p:nvPicPr>
-        <p:blipFill>
-          <a:blip r:embed="rId4"/>
-          <a:stretch>
-            <a:fillRect/>
-          </a:stretch>
-        </p:blipFill>
-        <p:spPr>
-          <a:xfrm>
-            <a:off x="1938739" y="603504"/>
-            <a:ext cx="2843948" cy="420624"/>
-          </a:xfrm>
-          <a:prstGeom prst="rect">
-            <a:avLst/>
-          </a:prstGeom>
-        </p:spPr>
-      </p:pic>
-      <p:sp>
-        <p:nvSpPr>
-          <p:cNvPr id="7" name="TextBox 6"/>
+            <a:ext cx="1463040" cy="420624"/>
+          </a:xfrm>
+          <a:prstGeom prst="rect">
+            <a:avLst/>
+          </a:prstGeom>
+          <a:noFill/>
+        </p:spPr>
+        <p:txBody>
+          <a:bodyPr wrap="square" lIns="0" rIns="0" tIns="0" bIns="0" anchor="t">
+            <a:spAutoFit/>
+          </a:bodyPr>
+          <a:lstStyle/>
+          <a:p>
+            <a:pPr algn="l">
+              <a:spcAft>
+                <a:spcPts val="0"/>
+              </a:spcAft>
+            </a:pPr>
+            <a:r>
+              <a:rPr sz="1000" b="1">
+                <a:solidFill>
+                  <a:srgbClr val="3366FF"/>
+                </a:solidFill>
+                <a:latin typeface="Libre Franklin"/>
+              </a:rPr>
+              <a:t>ESD Lab</a:t>
+            </a:r>
+          </a:p>
+        </p:txBody>
+      </p:sp>
+      <p:sp>
+        <p:nvSpPr>
+          <p:cNvPr id="5" name="TextBox 4"/>
+          <p:cNvSpPr txBox="1"/>
+          <p:nvPr/>
+        </p:nvSpPr>
+        <p:spPr>
+          <a:xfrm>
+            <a:off x="2505456" y="603504"/>
+            <a:ext cx="1280160" cy="420624"/>
+          </a:xfrm>
+          <a:prstGeom prst="rect">
+            <a:avLst/>
+          </a:prstGeom>
+          <a:noFill/>
+        </p:spPr>
+        <p:txBody>
+          <a:bodyPr wrap="square" lIns="0" rIns="0" tIns="0" bIns="0" anchor="t">
+            <a:spAutoFit/>
+          </a:bodyPr>
+          <a:lstStyle/>
+          <a:p>
+            <a:pPr algn="l">
+              <a:spcAft>
+                <a:spcPts val="0"/>
+              </a:spcAft>
+            </a:pPr>
+            <a:r>
+              <a:rPr sz="1000" b="1">
+                <a:solidFill>
+                  <a:srgbClr val="F57F00"/>
+                </a:solidFill>
+                <a:latin typeface="Libre Franklin"/>
+              </a:rPr>
+              <a:t>UofSC</a:t>
+            </a:r>
+          </a:p>
+        </p:txBody>
+      </p:sp>
+      <p:sp>
+        <p:nvSpPr>
+          <p:cNvPr id="6" name="TextBox 5"/>
           <p:cNvSpPr txBox="1"/>
           <p:nvPr/>
         </p:nvSpPr>
@@ -5042,7 +5048,7 @@
       </p:sp>
       <p:sp>
         <p:nvSpPr>
-          <p:cNvPr id="8" name="TextBox 7"/>
+          <p:cNvPr id="7" name="TextBox 6"/>
           <p:cNvSpPr txBox="1"/>
           <p:nvPr/>
         </p:nvSpPr>
@@ -5081,7 +5087,7 @@
       </p:sp>
       <p:sp>
         <p:nvSpPr>
-          <p:cNvPr id="9" name="TextBox 8"/>
+          <p:cNvPr id="8" name="TextBox 7"/>
           <p:cNvSpPr txBox="1"/>
           <p:nvPr/>
         </p:nvSpPr>
@@ -5280,30 +5286,45 @@
           </a:p>
         </p:txBody>
       </p:sp>
-      <p:pic>
-        <p:nvPicPr>
-          <p:cNvPr id="5" name="Picture 4" descr="logo-horizontal-discovery-blue.png"/>
-          <p:cNvPicPr>
-            <a:picLocks noChangeAspect="1"/>
-          </p:cNvPicPr>
-          <p:nvPr/>
-        </p:nvPicPr>
-        <p:blipFill>
-          <a:blip r:embed="rId2"/>
-          <a:stretch>
-            <a:fillRect/>
-          </a:stretch>
-        </p:blipFill>
+      <p:sp>
+        <p:nvSpPr>
+          <p:cNvPr id="5" name="TextBox 4"/>
+          <p:cNvSpPr txBox="1"/>
+          <p:nvPr/>
+        </p:nvSpPr>
         <p:spPr>
           <a:xfrm>
             <a:off x="11076127" y="402336"/>
-            <a:ext cx="565073" cy="265176"/>
-          </a:xfrm>
-          <a:prstGeom prst="rect">
-            <a:avLst/>
-          </a:prstGeom>
-        </p:spPr>
-      </p:pic>
+            <a:ext cx="1463040" cy="265176"/>
+          </a:xfrm>
+          <a:prstGeom prst="rect">
+            <a:avLst/>
+          </a:prstGeom>
+          <a:noFill/>
+        </p:spPr>
+        <p:txBody>
+          <a:bodyPr wrap="square" lIns="0" rIns="0" tIns="0" bIns="0" anchor="t">
+            <a:spAutoFit/>
+          </a:bodyPr>
+          <a:lstStyle/>
+          <a:p>
+            <a:pPr algn="l">
+              <a:spcAft>
+                <a:spcPts val="0"/>
+              </a:spcAft>
+            </a:pPr>
+            <a:r>
+              <a:rPr sz="1000" b="1">
+                <a:solidFill>
+                  <a:srgbClr val="3366FF"/>
+                </a:solidFill>
+                <a:latin typeface="Libre Franklin"/>
+              </a:rPr>
+              <a:t>ESD Lab</a:t>
+            </a:r>
+          </a:p>
+        </p:txBody>
+      </p:sp>
       <p:sp>
         <p:nvSpPr>
           <p:cNvPr id="6" name="Rounded Rectangle 5"/>
@@ -6744,30 +6765,45 @@
           </a:p>
         </p:txBody>
       </p:sp>
-      <p:pic>
-        <p:nvPicPr>
-          <p:cNvPr id="5" name="Picture 4" descr="logo-horizontal-discovery-blue.png"/>
-          <p:cNvPicPr>
-            <a:picLocks noChangeAspect="1"/>
-          </p:cNvPicPr>
-          <p:nvPr/>
-        </p:nvPicPr>
-        <p:blipFill>
-          <a:blip r:embed="rId2"/>
-          <a:stretch>
-            <a:fillRect/>
-          </a:stretch>
-        </p:blipFill>
+      <p:sp>
+        <p:nvSpPr>
+          <p:cNvPr id="5" name="TextBox 4"/>
+          <p:cNvSpPr txBox="1"/>
+          <p:nvPr/>
+        </p:nvSpPr>
         <p:spPr>
           <a:xfrm>
             <a:off x="11076127" y="402336"/>
-            <a:ext cx="565073" cy="265176"/>
-          </a:xfrm>
-          <a:prstGeom prst="rect">
-            <a:avLst/>
-          </a:prstGeom>
-        </p:spPr>
-      </p:pic>
+            <a:ext cx="1463040" cy="265176"/>
+          </a:xfrm>
+          <a:prstGeom prst="rect">
+            <a:avLst/>
+          </a:prstGeom>
+          <a:noFill/>
+        </p:spPr>
+        <p:txBody>
+          <a:bodyPr wrap="square" lIns="0" rIns="0" tIns="0" bIns="0" anchor="t">
+            <a:spAutoFit/>
+          </a:bodyPr>
+          <a:lstStyle/>
+          <a:p>
+            <a:pPr algn="l">
+              <a:spcAft>
+                <a:spcPts val="0"/>
+              </a:spcAft>
+            </a:pPr>
+            <a:r>
+              <a:rPr sz="1000" b="1">
+                <a:solidFill>
+                  <a:srgbClr val="3366FF"/>
+                </a:solidFill>
+                <a:latin typeface="Libre Franklin"/>
+              </a:rPr>
+              <a:t>ESD Lab</a:t>
+            </a:r>
+          </a:p>
+        </p:txBody>
+      </p:sp>
       <p:sp>
         <p:nvSpPr>
           <p:cNvPr id="6" name="Rounded Rectangle 5"/>
@@ -8235,30 +8271,45 @@
           </a:p>
         </p:txBody>
       </p:sp>
-      <p:pic>
-        <p:nvPicPr>
-          <p:cNvPr id="5" name="Picture 4" descr="logo-horizontal-discovery-blue.png"/>
-          <p:cNvPicPr>
-            <a:picLocks noChangeAspect="1"/>
-          </p:cNvPicPr>
-          <p:nvPr/>
-        </p:nvPicPr>
-        <p:blipFill>
-          <a:blip r:embed="rId2"/>
-          <a:stretch>
-            <a:fillRect/>
-          </a:stretch>
-        </p:blipFill>
+      <p:sp>
+        <p:nvSpPr>
+          <p:cNvPr id="5" name="TextBox 4"/>
+          <p:cNvSpPr txBox="1"/>
+          <p:nvPr/>
+        </p:nvSpPr>
         <p:spPr>
           <a:xfrm>
             <a:off x="11076127" y="402336"/>
-            <a:ext cx="565073" cy="265176"/>
-          </a:xfrm>
-          <a:prstGeom prst="rect">
-            <a:avLst/>
-          </a:prstGeom>
-        </p:spPr>
-      </p:pic>
+            <a:ext cx="1463040" cy="265176"/>
+          </a:xfrm>
+          <a:prstGeom prst="rect">
+            <a:avLst/>
+          </a:prstGeom>
+          <a:noFill/>
+        </p:spPr>
+        <p:txBody>
+          <a:bodyPr wrap="square" lIns="0" rIns="0" tIns="0" bIns="0" anchor="t">
+            <a:spAutoFit/>
+          </a:bodyPr>
+          <a:lstStyle/>
+          <a:p>
+            <a:pPr algn="l">
+              <a:spcAft>
+                <a:spcPts val="0"/>
+              </a:spcAft>
+            </a:pPr>
+            <a:r>
+              <a:rPr sz="1000" b="1">
+                <a:solidFill>
+                  <a:srgbClr val="3366FF"/>
+                </a:solidFill>
+                <a:latin typeface="Libre Franklin"/>
+              </a:rPr>
+              <a:t>ESD Lab</a:t>
+            </a:r>
+          </a:p>
+        </p:txBody>
+      </p:sp>
       <p:sp>
         <p:nvSpPr>
           <p:cNvPr id="6" name="Rounded Rectangle 5"/>
@@ -8314,7 +8365,7 @@
           <p:nvPr/>
         </p:nvPicPr>
         <p:blipFill>
-          <a:blip r:embed="rId3"/>
+          <a:blip r:embed="rId2"/>
           <a:stretch>
             <a:fillRect/>
           </a:stretch>
@@ -8547,7 +8598,7 @@
         </p:nvSpPr>
         <p:spPr>
           <a:xfrm>
-            <a:off x="7936992" y="3034893"/>
+            <a:off x="7936992" y="2889961"/>
             <a:ext cx="219456" cy="219456"/>
           </a:xfrm>
           <a:prstGeom prst="ellipse">
@@ -8591,7 +8642,7 @@
         </p:nvSpPr>
         <p:spPr>
           <a:xfrm>
-            <a:off x="7936992" y="3062325"/>
+            <a:off x="7936992" y="2917393"/>
             <a:ext cx="219456" cy="182880"/>
           </a:xfrm>
           <a:prstGeom prst="rect">
@@ -8630,7 +8681,7 @@
         </p:nvSpPr>
         <p:spPr>
           <a:xfrm>
-            <a:off x="8247888" y="3021177"/>
+            <a:off x="8247888" y="2876245"/>
             <a:ext cx="3136391" cy="822960"/>
           </a:xfrm>
           <a:prstGeom prst="rect">
@@ -8672,7 +8723,7 @@
         </p:nvSpPr>
         <p:spPr>
           <a:xfrm>
-            <a:off x="7936992" y="3879799"/>
+            <a:off x="7936992" y="3589934"/>
             <a:ext cx="219456" cy="219456"/>
           </a:xfrm>
           <a:prstGeom prst="ellipse">
@@ -8716,7 +8767,7 @@
         </p:nvSpPr>
         <p:spPr>
           <a:xfrm>
-            <a:off x="7936992" y="3907231"/>
+            <a:off x="7936992" y="3617366"/>
             <a:ext cx="219456" cy="182880"/>
           </a:xfrm>
           <a:prstGeom prst="rect">
@@ -8755,7 +8806,7 @@
         </p:nvSpPr>
         <p:spPr>
           <a:xfrm>
-            <a:off x="8247888" y="3866083"/>
+            <a:off x="8247888" y="3576218"/>
             <a:ext cx="3136391" cy="822960"/>
           </a:xfrm>
           <a:prstGeom prst="rect">
@@ -8974,30 +9025,45 @@
           </a:p>
         </p:txBody>
       </p:sp>
-      <p:pic>
-        <p:nvPicPr>
-          <p:cNvPr id="5" name="Picture 4" descr="logo-horizontal-discovery-blue.png"/>
-          <p:cNvPicPr>
-            <a:picLocks noChangeAspect="1"/>
-          </p:cNvPicPr>
-          <p:nvPr/>
-        </p:nvPicPr>
-        <p:blipFill>
-          <a:blip r:embed="rId2"/>
-          <a:stretch>
-            <a:fillRect/>
-          </a:stretch>
-        </p:blipFill>
+      <p:sp>
+        <p:nvSpPr>
+          <p:cNvPr id="5" name="TextBox 4"/>
+          <p:cNvSpPr txBox="1"/>
+          <p:nvPr/>
+        </p:nvSpPr>
         <p:spPr>
           <a:xfrm>
             <a:off x="11076127" y="402336"/>
-            <a:ext cx="565073" cy="265176"/>
-          </a:xfrm>
-          <a:prstGeom prst="rect">
-            <a:avLst/>
-          </a:prstGeom>
-        </p:spPr>
-      </p:pic>
+            <a:ext cx="1463040" cy="265176"/>
+          </a:xfrm>
+          <a:prstGeom prst="rect">
+            <a:avLst/>
+          </a:prstGeom>
+          <a:noFill/>
+        </p:spPr>
+        <p:txBody>
+          <a:bodyPr wrap="square" lIns="0" rIns="0" tIns="0" bIns="0" anchor="t">
+            <a:spAutoFit/>
+          </a:bodyPr>
+          <a:lstStyle/>
+          <a:p>
+            <a:pPr algn="l">
+              <a:spcAft>
+                <a:spcPts val="0"/>
+              </a:spcAft>
+            </a:pPr>
+            <a:r>
+              <a:rPr sz="1000" b="1">
+                <a:solidFill>
+                  <a:srgbClr val="3366FF"/>
+                </a:solidFill>
+                <a:latin typeface="Libre Franklin"/>
+              </a:rPr>
+              <a:t>ESD Lab</a:t>
+            </a:r>
+          </a:p>
+        </p:txBody>
+      </p:sp>
       <p:sp>
         <p:nvSpPr>
           <p:cNvPr id="6" name="Rounded Rectangle 5"/>
@@ -9053,7 +9119,7 @@
           <p:nvPr/>
         </p:nvPicPr>
         <p:blipFill>
-          <a:blip r:embed="rId3"/>
+          <a:blip r:embed="rId2"/>
           <a:stretch>
             <a:fillRect/>
           </a:stretch>
@@ -9798,30 +9864,45 @@
           </a:p>
         </p:txBody>
       </p:sp>
-      <p:pic>
-        <p:nvPicPr>
-          <p:cNvPr id="5" name="Picture 4" descr="logo-horizontal-discovery-blue.png"/>
-          <p:cNvPicPr>
-            <a:picLocks noChangeAspect="1"/>
-          </p:cNvPicPr>
-          <p:nvPr/>
-        </p:nvPicPr>
-        <p:blipFill>
-          <a:blip r:embed="rId2"/>
-          <a:stretch>
-            <a:fillRect/>
-          </a:stretch>
-        </p:blipFill>
+      <p:sp>
+        <p:nvSpPr>
+          <p:cNvPr id="5" name="TextBox 4"/>
+          <p:cNvSpPr txBox="1"/>
+          <p:nvPr/>
+        </p:nvSpPr>
         <p:spPr>
           <a:xfrm>
             <a:off x="11076127" y="402336"/>
-            <a:ext cx="565073" cy="265176"/>
-          </a:xfrm>
-          <a:prstGeom prst="rect">
-            <a:avLst/>
-          </a:prstGeom>
-        </p:spPr>
-      </p:pic>
+            <a:ext cx="1463040" cy="265176"/>
+          </a:xfrm>
+          <a:prstGeom prst="rect">
+            <a:avLst/>
+          </a:prstGeom>
+          <a:noFill/>
+        </p:spPr>
+        <p:txBody>
+          <a:bodyPr wrap="square" lIns="0" rIns="0" tIns="0" bIns="0" anchor="t">
+            <a:spAutoFit/>
+          </a:bodyPr>
+          <a:lstStyle/>
+          <a:p>
+            <a:pPr algn="l">
+              <a:spcAft>
+                <a:spcPts val="0"/>
+              </a:spcAft>
+            </a:pPr>
+            <a:r>
+              <a:rPr sz="1000" b="1">
+                <a:solidFill>
+                  <a:srgbClr val="3366FF"/>
+                </a:solidFill>
+                <a:latin typeface="Libre Franklin"/>
+              </a:rPr>
+              <a:t>ESD Lab</a:t>
+            </a:r>
+          </a:p>
+        </p:txBody>
+      </p:sp>
       <p:sp>
         <p:nvSpPr>
           <p:cNvPr id="6" name="Rounded Rectangle 5"/>
@@ -9877,7 +9958,7 @@
           <p:nvPr/>
         </p:nvPicPr>
         <p:blipFill>
-          <a:blip r:embed="rId3"/>
+          <a:blip r:embed="rId2"/>
           <a:stretch>
             <a:fillRect/>
           </a:stretch>
@@ -10662,30 +10743,45 @@
           </a:p>
         </p:txBody>
       </p:sp>
-      <p:pic>
-        <p:nvPicPr>
-          <p:cNvPr id="5" name="Picture 4" descr="logo-horizontal-discovery-blue.png"/>
-          <p:cNvPicPr>
-            <a:picLocks noChangeAspect="1"/>
-          </p:cNvPicPr>
-          <p:nvPr/>
-        </p:nvPicPr>
-        <p:blipFill>
-          <a:blip r:embed="rId2"/>
-          <a:stretch>
-            <a:fillRect/>
-          </a:stretch>
-        </p:blipFill>
+      <p:sp>
+        <p:nvSpPr>
+          <p:cNvPr id="5" name="TextBox 4"/>
+          <p:cNvSpPr txBox="1"/>
+          <p:nvPr/>
+        </p:nvSpPr>
         <p:spPr>
           <a:xfrm>
             <a:off x="11076127" y="402336"/>
-            <a:ext cx="565073" cy="265176"/>
-          </a:xfrm>
-          <a:prstGeom prst="rect">
-            <a:avLst/>
-          </a:prstGeom>
-        </p:spPr>
-      </p:pic>
+            <a:ext cx="1463040" cy="265176"/>
+          </a:xfrm>
+          <a:prstGeom prst="rect">
+            <a:avLst/>
+          </a:prstGeom>
+          <a:noFill/>
+        </p:spPr>
+        <p:txBody>
+          <a:bodyPr wrap="square" lIns="0" rIns="0" tIns="0" bIns="0" anchor="t">
+            <a:spAutoFit/>
+          </a:bodyPr>
+          <a:lstStyle/>
+          <a:p>
+            <a:pPr algn="l">
+              <a:spcAft>
+                <a:spcPts val="0"/>
+              </a:spcAft>
+            </a:pPr>
+            <a:r>
+              <a:rPr sz="1000" b="1">
+                <a:solidFill>
+                  <a:srgbClr val="3366FF"/>
+                </a:solidFill>
+                <a:latin typeface="Libre Franklin"/>
+              </a:rPr>
+              <a:t>ESD Lab</a:t>
+            </a:r>
+          </a:p>
+        </p:txBody>
+      </p:sp>
       <p:sp>
         <p:nvSpPr>
           <p:cNvPr id="6" name="Rounded Rectangle 5"/>
@@ -10741,7 +10837,7 @@
           <p:nvPr/>
         </p:nvPicPr>
         <p:blipFill>
-          <a:blip r:embed="rId3"/>
+          <a:blip r:embed="rId2"/>
           <a:stretch>
             <a:fillRect/>
           </a:stretch>
@@ -11486,30 +11582,45 @@
           </a:p>
         </p:txBody>
       </p:sp>
-      <p:pic>
-        <p:nvPicPr>
-          <p:cNvPr id="5" name="Picture 4" descr="logo-horizontal-discovery-blue.png"/>
-          <p:cNvPicPr>
-            <a:picLocks noChangeAspect="1"/>
-          </p:cNvPicPr>
-          <p:nvPr/>
-        </p:nvPicPr>
-        <p:blipFill>
-          <a:blip r:embed="rId2"/>
-          <a:stretch>
-            <a:fillRect/>
-          </a:stretch>
-        </p:blipFill>
+      <p:sp>
+        <p:nvSpPr>
+          <p:cNvPr id="5" name="TextBox 4"/>
+          <p:cNvSpPr txBox="1"/>
+          <p:nvPr/>
+        </p:nvSpPr>
         <p:spPr>
           <a:xfrm>
             <a:off x="11076127" y="402336"/>
-            <a:ext cx="565073" cy="265176"/>
-          </a:xfrm>
-          <a:prstGeom prst="rect">
-            <a:avLst/>
-          </a:prstGeom>
-        </p:spPr>
-      </p:pic>
+            <a:ext cx="1463040" cy="265176"/>
+          </a:xfrm>
+          <a:prstGeom prst="rect">
+            <a:avLst/>
+          </a:prstGeom>
+          <a:noFill/>
+        </p:spPr>
+        <p:txBody>
+          <a:bodyPr wrap="square" lIns="0" rIns="0" tIns="0" bIns="0" anchor="t">
+            <a:spAutoFit/>
+          </a:bodyPr>
+          <a:lstStyle/>
+          <a:p>
+            <a:pPr algn="l">
+              <a:spcAft>
+                <a:spcPts val="0"/>
+              </a:spcAft>
+            </a:pPr>
+            <a:r>
+              <a:rPr sz="1000" b="1">
+                <a:solidFill>
+                  <a:srgbClr val="3366FF"/>
+                </a:solidFill>
+                <a:latin typeface="Libre Franklin"/>
+              </a:rPr>
+              <a:t>ESD Lab</a:t>
+            </a:r>
+          </a:p>
+        </p:txBody>
+      </p:sp>
       <p:graphicFrame>
         <p:nvGraphicFramePr>
           <p:cNvPr id="6" name="Chart 5"/>
@@ -11524,7 +11635,7 @@
         </p:xfrm>
         <a:graphic>
           <a:graphicData uri="http://schemas.openxmlformats.org/drawingml/2006/chart">
-            <c:chart xmlns:c="http://schemas.openxmlformats.org/drawingml/2006/chart" r:id="rId3"/>
+            <c:chart xmlns:c="http://schemas.openxmlformats.org/drawingml/2006/chart" r:id="rId2"/>
           </a:graphicData>
         </a:graphic>
       </p:graphicFrame>
@@ -12258,30 +12369,45 @@
           </a:p>
         </p:txBody>
       </p:sp>
-      <p:pic>
-        <p:nvPicPr>
-          <p:cNvPr id="5" name="Picture 4" descr="logo-horizontal-discovery-blue.png"/>
-          <p:cNvPicPr>
-            <a:picLocks noChangeAspect="1"/>
-          </p:cNvPicPr>
-          <p:nvPr/>
-        </p:nvPicPr>
-        <p:blipFill>
-          <a:blip r:embed="rId2"/>
-          <a:stretch>
-            <a:fillRect/>
-          </a:stretch>
-        </p:blipFill>
+      <p:sp>
+        <p:nvSpPr>
+          <p:cNvPr id="5" name="TextBox 4"/>
+          <p:cNvSpPr txBox="1"/>
+          <p:nvPr/>
+        </p:nvSpPr>
         <p:spPr>
           <a:xfrm>
             <a:off x="11076127" y="402336"/>
-            <a:ext cx="565073" cy="265176"/>
-          </a:xfrm>
-          <a:prstGeom prst="rect">
-            <a:avLst/>
-          </a:prstGeom>
-        </p:spPr>
-      </p:pic>
+            <a:ext cx="1463040" cy="265176"/>
+          </a:xfrm>
+          <a:prstGeom prst="rect">
+            <a:avLst/>
+          </a:prstGeom>
+          <a:noFill/>
+        </p:spPr>
+        <p:txBody>
+          <a:bodyPr wrap="square" lIns="0" rIns="0" tIns="0" bIns="0" anchor="t">
+            <a:spAutoFit/>
+          </a:bodyPr>
+          <a:lstStyle/>
+          <a:p>
+            <a:pPr algn="l">
+              <a:spcAft>
+                <a:spcPts val="0"/>
+              </a:spcAft>
+            </a:pPr>
+            <a:r>
+              <a:rPr sz="1000" b="1">
+                <a:solidFill>
+                  <a:srgbClr val="3366FF"/>
+                </a:solidFill>
+                <a:latin typeface="Libre Franklin"/>
+              </a:rPr>
+              <a:t>ESD Lab</a:t>
+            </a:r>
+          </a:p>
+        </p:txBody>
+      </p:sp>
       <p:sp>
         <p:nvSpPr>
           <p:cNvPr id="6" name="Rounded Rectangle 5"/>
@@ -14033,30 +14159,45 @@
           </a:p>
         </p:txBody>
       </p:sp>
-      <p:pic>
-        <p:nvPicPr>
-          <p:cNvPr id="5" name="Picture 4" descr="logo-horizontal-discovery-blue.png"/>
-          <p:cNvPicPr>
-            <a:picLocks noChangeAspect="1"/>
-          </p:cNvPicPr>
-          <p:nvPr/>
-        </p:nvPicPr>
-        <p:blipFill>
-          <a:blip r:embed="rId2"/>
-          <a:stretch>
-            <a:fillRect/>
-          </a:stretch>
-        </p:blipFill>
+      <p:sp>
+        <p:nvSpPr>
+          <p:cNvPr id="5" name="TextBox 4"/>
+          <p:cNvSpPr txBox="1"/>
+          <p:nvPr/>
+        </p:nvSpPr>
         <p:spPr>
           <a:xfrm>
             <a:off x="11076127" y="402336"/>
-            <a:ext cx="565073" cy="265176"/>
-          </a:xfrm>
-          <a:prstGeom prst="rect">
-            <a:avLst/>
-          </a:prstGeom>
-        </p:spPr>
-      </p:pic>
+            <a:ext cx="1463040" cy="265176"/>
+          </a:xfrm>
+          <a:prstGeom prst="rect">
+            <a:avLst/>
+          </a:prstGeom>
+          <a:noFill/>
+        </p:spPr>
+        <p:txBody>
+          <a:bodyPr wrap="square" lIns="0" rIns="0" tIns="0" bIns="0" anchor="t">
+            <a:spAutoFit/>
+          </a:bodyPr>
+          <a:lstStyle/>
+          <a:p>
+            <a:pPr algn="l">
+              <a:spcAft>
+                <a:spcPts val="0"/>
+              </a:spcAft>
+            </a:pPr>
+            <a:r>
+              <a:rPr sz="1000" b="1">
+                <a:solidFill>
+                  <a:srgbClr val="3366FF"/>
+                </a:solidFill>
+                <a:latin typeface="Libre Franklin"/>
+              </a:rPr>
+              <a:t>ESD Lab</a:t>
+            </a:r>
+          </a:p>
+        </p:txBody>
+      </p:sp>
       <p:sp>
         <p:nvSpPr>
           <p:cNvPr id="6" name="Rounded Rectangle 5"/>
@@ -14112,7 +14253,7 @@
           <p:nvPr/>
         </p:nvPicPr>
         <p:blipFill>
-          <a:blip r:embed="rId3"/>
+          <a:blip r:embed="rId2"/>
           <a:stretch>
             <a:fillRect/>
           </a:stretch>

</xml_diff>